<commit_message>
Deploying website to gh-pages
</commit_message>
<xml_diff>
--- a/slides/dummy/dummy_vars2026.pptx
+++ b/slides/dummy/dummy_vars2026.pptx
@@ -8324,7 +8324,7 @@
                 <a:latin typeface="Arial" panose="020B0604020202020204" pitchFamily="34" charset="0"/>
                 <a:cs typeface="Arial" panose="020B0604020202020204" pitchFamily="34" charset="0"/>
               </a:rPr>
-              <a:t>then the dummy variable equals </a:t>
+              <a:t>Then the dummy variable equals </a:t>
             </a:r>
             <a:r>
               <a:rPr lang="en-US" sz="2000" b="1" dirty="0">
@@ -8464,7 +8464,7 @@
         </p:spPr>
         <p:txBody>
           <a:bodyPr>
-            <a:normAutofit lnSpcReduction="10000"/>
+            <a:normAutofit fontScale="92500" lnSpcReduction="10000"/>
           </a:bodyPr>
           <a:lstStyle/>
           <a:p>
@@ -8479,7 +8479,7 @@
           <a:p>
             <a:pPr lvl="1"/>
             <a:r>
-              <a:rPr lang="en-US" altLang="en-US" sz="1600" dirty="0">
+              <a:rPr lang="en-US" altLang="en-US" sz="2000" dirty="0">
                 <a:latin typeface="Arial" panose="020B0604020202020204" pitchFamily="34" charset="0"/>
                 <a:cs typeface="Arial" panose="020B0604020202020204" pitchFamily="34" charset="0"/>
               </a:rPr>
@@ -8526,7 +8526,7 @@
           <a:p>
             <a:pPr lvl="1"/>
             <a:r>
-              <a:rPr lang="en-US" sz="1600" dirty="0">
+              <a:rPr lang="en-US" sz="2000" dirty="0">
                 <a:latin typeface="Arial" panose="020B0604020202020204" pitchFamily="34" charset="0"/>
                 <a:cs typeface="Arial" panose="020B0604020202020204" pitchFamily="34" charset="0"/>
               </a:rPr>
@@ -8536,21 +8536,21 @@
           <a:p>
             <a:pPr lvl="1"/>
             <a:r>
-              <a:rPr lang="en-US" altLang="en-US" sz="1600" dirty="0">
+              <a:rPr lang="en-US" altLang="en-US" sz="2000" dirty="0">
                 <a:latin typeface="Arial" panose="020B0604020202020204" pitchFamily="34" charset="0"/>
                 <a:cs typeface="Arial" panose="020B0604020202020204" pitchFamily="34" charset="0"/>
               </a:rPr>
               <a:t>The baseline level of the categorical variable for which all </a:t>
             </a:r>
             <a:r>
-              <a:rPr lang="en-US" altLang="en-US" sz="1600" i="1" dirty="0">
+              <a:rPr lang="en-US" altLang="en-US" sz="2000" i="1" dirty="0">
                 <a:latin typeface="Arial" panose="020B0604020202020204" pitchFamily="34" charset="0"/>
                 <a:cs typeface="Arial" panose="020B0604020202020204" pitchFamily="34" charset="0"/>
               </a:rPr>
               <a:t>k</a:t>
             </a:r>
             <a:r>
-              <a:rPr lang="en-US" altLang="en-US" sz="1600" dirty="0">
+              <a:rPr lang="en-US" altLang="en-US" sz="2000" dirty="0">
                 <a:latin typeface="Arial" panose="020B0604020202020204" pitchFamily="34" charset="0"/>
                 <a:cs typeface="Arial" panose="020B0604020202020204" pitchFamily="34" charset="0"/>
               </a:rPr>
@@ -8560,13 +8560,13 @@
           <a:p>
             <a:pPr lvl="1"/>
             <a:r>
-              <a:rPr lang="en-US" sz="1600" dirty="0">
+              <a:rPr lang="en-US" sz="2000" dirty="0">
                 <a:latin typeface="Arial" panose="020B0604020202020204" pitchFamily="34" charset="0"/>
                 <a:cs typeface="Arial" panose="020B0604020202020204" pitchFamily="34" charset="0"/>
               </a:rPr>
               <a:t>This avoids a problem called perfect multicollinearity, where including all k categories would create redundant information and make the model impossible to estimate	</a:t>
             </a:r>
-            <a:endParaRPr lang="en-US" altLang="en-US" sz="1600" dirty="0">
+            <a:endParaRPr lang="en-US" altLang="en-US" sz="2000" dirty="0">
               <a:latin typeface="Arial" panose="020B0604020202020204" pitchFamily="34" charset="0"/>
               <a:cs typeface="Arial" panose="020B0604020202020204" pitchFamily="34" charset="0"/>
             </a:endParaRPr>
@@ -8583,7 +8583,7 @@
           <a:p>
             <a:pPr lvl="1"/>
             <a:r>
-              <a:rPr lang="en-US" sz="1600" dirty="0">
+              <a:rPr lang="en-US" sz="2000" dirty="0">
                 <a:latin typeface="Arial" panose="020B0604020202020204" pitchFamily="34" charset="0"/>
                 <a:cs typeface="Arial" panose="020B0604020202020204" pitchFamily="34" charset="0"/>
               </a:rPr>
@@ -8593,7 +8593,7 @@
           <a:p>
             <a:pPr lvl="1"/>
             <a:r>
-              <a:rPr lang="en-US" sz="1600" dirty="0">
+              <a:rPr lang="en-US" sz="2000" dirty="0">
                 <a:latin typeface="Arial" panose="020B0604020202020204" pitchFamily="34" charset="0"/>
                 <a:cs typeface="Arial" panose="020B0604020202020204" pitchFamily="34" charset="0"/>
               </a:rPr>
@@ -22632,7 +22632,13 @@
                           <a:rPr lang="en-US" sz="2000" b="0" i="1" smtClean="0">
                             <a:latin typeface="Cambria Math" panose="02040503050406030204" pitchFamily="18" charset="0"/>
                           </a:rPr>
-                          <m:t>=40</m:t>
+                          <m:t>=</m:t>
+                        </m:r>
+                        <m:r>
+                          <a:rPr lang="en-US" sz="2000" b="0" i="1" smtClean="0">
+                            <a:latin typeface="Cambria Math" panose="02040503050406030204" pitchFamily="18" charset="0"/>
+                          </a:rPr>
+                          <m:t>40</m:t>
                         </m:r>
                       </m:sub>
                     </m:sSub>
@@ -22640,7 +22646,13 @@
                       <a:rPr lang="en-US" sz="2000" b="0" i="1" smtClean="0">
                         <a:latin typeface="Cambria Math" panose="02040503050406030204" pitchFamily="18" charset="0"/>
                       </a:rPr>
-                      <m:t>=69</m:t>
+                      <m:t>=</m:t>
+                    </m:r>
+                    <m:r>
+                      <a:rPr lang="en-US" sz="2000" b="0" i="1" smtClean="0">
+                        <a:latin typeface="Cambria Math" panose="02040503050406030204" pitchFamily="18" charset="0"/>
+                      </a:rPr>
+                      <m:t>69</m:t>
                     </m:r>
                   </m:oMath>
                 </a14:m>
@@ -22672,7 +22684,14 @@
                         <a:latin typeface="Cambria Math" panose="02040503050406030204" pitchFamily="18" charset="0"/>
                         <a:ea typeface="Cambria Math" panose="02040503050406030204" pitchFamily="18" charset="0"/>
                       </a:rPr>
-                      <m:t>=4</m:t>
+                      <m:t>=</m:t>
+                    </m:r>
+                    <m:r>
+                      <a:rPr lang="en-US" sz="2000" b="0" i="1" smtClean="0">
+                        <a:latin typeface="Cambria Math" panose="02040503050406030204" pitchFamily="18" charset="0"/>
+                        <a:ea typeface="Cambria Math" panose="02040503050406030204" pitchFamily="18" charset="0"/>
+                      </a:rPr>
+                      <m:t>4</m:t>
                     </m:r>
                   </m:oMath>
                 </a14:m>
@@ -22822,7 +22841,13 @@
                       <a:rPr lang="en-US" sz="2000" b="0" i="1" smtClean="0">
                         <a:latin typeface="Cambria Math" panose="02040503050406030204" pitchFamily="18" charset="0"/>
                       </a:rPr>
-                      <m:t>=.63</m:t>
+                      <m:t>=.</m:t>
+                    </m:r>
+                    <m:r>
+                      <a:rPr lang="en-US" sz="2000" b="0" i="1" smtClean="0">
+                        <a:latin typeface="Cambria Math" panose="02040503050406030204" pitchFamily="18" charset="0"/>
+                      </a:rPr>
+                      <m:t>63</m:t>
                     </m:r>
                   </m:oMath>
                 </a14:m>
@@ -22928,7 +22953,14 @@
                                 <a:latin typeface="Cambria Math" panose="02040503050406030204" pitchFamily="18" charset="0"/>
                                 <a:ea typeface="Cambria Math" panose="02040503050406030204" pitchFamily="18" charset="0"/>
                               </a:rPr>
-                              <m:t>.05</m:t>
+                              <m:t>.</m:t>
+                            </m:r>
+                            <m:r>
+                              <a:rPr lang="en-US" sz="2000" b="0" i="1" smtClean="0">
+                                <a:latin typeface="Cambria Math" panose="02040503050406030204" pitchFamily="18" charset="0"/>
+                                <a:ea typeface="Cambria Math" panose="02040503050406030204" pitchFamily="18" charset="0"/>
+                              </a:rPr>
+                              <m:t>05</m:t>
                             </m:r>
                           </m:num>
                           <m:den>
@@ -22969,7 +23001,13 @@
                           <a:rPr lang="en-US" sz="2000" b="0" i="1" smtClean="0">
                             <a:latin typeface="Cambria Math" panose="02040503050406030204" pitchFamily="18" charset="0"/>
                           </a:rPr>
-                          <m:t>.025</m:t>
+                          <m:t>.</m:t>
+                        </m:r>
+                        <m:r>
+                          <a:rPr lang="en-US" sz="2000" b="0" i="1" smtClean="0">
+                            <a:latin typeface="Cambria Math" panose="02040503050406030204" pitchFamily="18" charset="0"/>
+                          </a:rPr>
+                          <m:t>025</m:t>
                         </m:r>
                       </m:sub>
                     </m:sSub>
@@ -23835,7 +23873,262 @@
                               <a:ea typeface="+mn-ea"/>
                               <a:cs typeface="+mn-cs"/>
                             </a:rPr>
-                            <m:t>69−1.96(.63),69+1.96(.63) </m:t>
+                            <m:t>69</m:t>
+                          </m:r>
+                          <m:r>
+                            <a:rPr kumimoji="0" lang="en-US" sz="1800" b="0" i="1" u="none" strike="noStrike" kern="1200" cap="none" spc="0" normalizeH="0" baseline="0" noProof="0" smtClean="0">
+                              <a:ln>
+                                <a:noFill/>
+                              </a:ln>
+                              <a:solidFill>
+                                <a:prstClr val="black"/>
+                              </a:solidFill>
+                              <a:effectLst/>
+                              <a:uLnTx/>
+                              <a:uFillTx/>
+                              <a:latin typeface="Cambria Math" panose="02040503050406030204" pitchFamily="18" charset="0"/>
+                              <a:ea typeface="+mn-ea"/>
+                              <a:cs typeface="+mn-cs"/>
+                            </a:rPr>
+                            <m:t>−</m:t>
+                          </m:r>
+                          <m:r>
+                            <a:rPr kumimoji="0" lang="en-US" sz="1800" b="0" i="1" u="none" strike="noStrike" kern="1200" cap="none" spc="0" normalizeH="0" baseline="0" noProof="0" smtClean="0">
+                              <a:ln>
+                                <a:noFill/>
+                              </a:ln>
+                              <a:solidFill>
+                                <a:prstClr val="black"/>
+                              </a:solidFill>
+                              <a:effectLst/>
+                              <a:uLnTx/>
+                              <a:uFillTx/>
+                              <a:latin typeface="Cambria Math" panose="02040503050406030204" pitchFamily="18" charset="0"/>
+                              <a:ea typeface="+mn-ea"/>
+                              <a:cs typeface="+mn-cs"/>
+                            </a:rPr>
+                            <m:t>1</m:t>
+                          </m:r>
+                          <m:r>
+                            <a:rPr kumimoji="0" lang="en-US" sz="1800" b="0" i="1" u="none" strike="noStrike" kern="1200" cap="none" spc="0" normalizeH="0" baseline="0" noProof="0" smtClean="0">
+                              <a:ln>
+                                <a:noFill/>
+                              </a:ln>
+                              <a:solidFill>
+                                <a:prstClr val="black"/>
+                              </a:solidFill>
+                              <a:effectLst/>
+                              <a:uLnTx/>
+                              <a:uFillTx/>
+                              <a:latin typeface="Cambria Math" panose="02040503050406030204" pitchFamily="18" charset="0"/>
+                              <a:ea typeface="+mn-ea"/>
+                              <a:cs typeface="+mn-cs"/>
+                            </a:rPr>
+                            <m:t>.</m:t>
+                          </m:r>
+                          <m:r>
+                            <a:rPr kumimoji="0" lang="en-US" sz="1800" b="0" i="1" u="none" strike="noStrike" kern="1200" cap="none" spc="0" normalizeH="0" baseline="0" noProof="0" smtClean="0">
+                              <a:ln>
+                                <a:noFill/>
+                              </a:ln>
+                              <a:solidFill>
+                                <a:prstClr val="black"/>
+                              </a:solidFill>
+                              <a:effectLst/>
+                              <a:uLnTx/>
+                              <a:uFillTx/>
+                              <a:latin typeface="Cambria Math" panose="02040503050406030204" pitchFamily="18" charset="0"/>
+                              <a:ea typeface="+mn-ea"/>
+                              <a:cs typeface="+mn-cs"/>
+                            </a:rPr>
+                            <m:t>96</m:t>
+                          </m:r>
+                          <m:r>
+                            <a:rPr kumimoji="0" lang="en-US" sz="1800" b="0" i="1" u="none" strike="noStrike" kern="1200" cap="none" spc="0" normalizeH="0" baseline="0" noProof="0" smtClean="0">
+                              <a:ln>
+                                <a:noFill/>
+                              </a:ln>
+                              <a:solidFill>
+                                <a:prstClr val="black"/>
+                              </a:solidFill>
+                              <a:effectLst/>
+                              <a:uLnTx/>
+                              <a:uFillTx/>
+                              <a:latin typeface="Cambria Math" panose="02040503050406030204" pitchFamily="18" charset="0"/>
+                              <a:ea typeface="+mn-ea"/>
+                              <a:cs typeface="+mn-cs"/>
+                            </a:rPr>
+                            <m:t>(.</m:t>
+                          </m:r>
+                          <m:r>
+                            <a:rPr kumimoji="0" lang="en-US" sz="1800" b="0" i="1" u="none" strike="noStrike" kern="1200" cap="none" spc="0" normalizeH="0" baseline="0" noProof="0" smtClean="0">
+                              <a:ln>
+                                <a:noFill/>
+                              </a:ln>
+                              <a:solidFill>
+                                <a:prstClr val="black"/>
+                              </a:solidFill>
+                              <a:effectLst/>
+                              <a:uLnTx/>
+                              <a:uFillTx/>
+                              <a:latin typeface="Cambria Math" panose="02040503050406030204" pitchFamily="18" charset="0"/>
+                              <a:ea typeface="+mn-ea"/>
+                              <a:cs typeface="+mn-cs"/>
+                            </a:rPr>
+                            <m:t>63</m:t>
+                          </m:r>
+                          <m:r>
+                            <a:rPr kumimoji="0" lang="en-US" sz="1800" b="0" i="1" u="none" strike="noStrike" kern="1200" cap="none" spc="0" normalizeH="0" baseline="0" noProof="0" smtClean="0">
+                              <a:ln>
+                                <a:noFill/>
+                              </a:ln>
+                              <a:solidFill>
+                                <a:prstClr val="black"/>
+                              </a:solidFill>
+                              <a:effectLst/>
+                              <a:uLnTx/>
+                              <a:uFillTx/>
+                              <a:latin typeface="Cambria Math" panose="02040503050406030204" pitchFamily="18" charset="0"/>
+                              <a:ea typeface="+mn-ea"/>
+                              <a:cs typeface="+mn-cs"/>
+                            </a:rPr>
+                            <m:t>),</m:t>
+                          </m:r>
+                          <m:r>
+                            <a:rPr kumimoji="0" lang="en-US" sz="1800" b="0" i="1" u="none" strike="noStrike" kern="1200" cap="none" spc="0" normalizeH="0" baseline="0" noProof="0" smtClean="0">
+                              <a:ln>
+                                <a:noFill/>
+                              </a:ln>
+                              <a:solidFill>
+                                <a:prstClr val="black"/>
+                              </a:solidFill>
+                              <a:effectLst/>
+                              <a:uLnTx/>
+                              <a:uFillTx/>
+                              <a:latin typeface="Cambria Math" panose="02040503050406030204" pitchFamily="18" charset="0"/>
+                              <a:ea typeface="+mn-ea"/>
+                              <a:cs typeface="+mn-cs"/>
+                            </a:rPr>
+                            <m:t>69</m:t>
+                          </m:r>
+                          <m:r>
+                            <a:rPr kumimoji="0" lang="en-US" sz="1800" b="0" i="1" u="none" strike="noStrike" kern="1200" cap="none" spc="0" normalizeH="0" baseline="0" noProof="0" smtClean="0">
+                              <a:ln>
+                                <a:noFill/>
+                              </a:ln>
+                              <a:solidFill>
+                                <a:prstClr val="black"/>
+                              </a:solidFill>
+                              <a:effectLst/>
+                              <a:uLnTx/>
+                              <a:uFillTx/>
+                              <a:latin typeface="Cambria Math" panose="02040503050406030204" pitchFamily="18" charset="0"/>
+                              <a:ea typeface="+mn-ea"/>
+                              <a:cs typeface="+mn-cs"/>
+                            </a:rPr>
+                            <m:t>+</m:t>
+                          </m:r>
+                          <m:r>
+                            <a:rPr kumimoji="0" lang="en-US" sz="1800" b="0" i="1" u="none" strike="noStrike" kern="1200" cap="none" spc="0" normalizeH="0" baseline="0" noProof="0" smtClean="0">
+                              <a:ln>
+                                <a:noFill/>
+                              </a:ln>
+                              <a:solidFill>
+                                <a:prstClr val="black"/>
+                              </a:solidFill>
+                              <a:effectLst/>
+                              <a:uLnTx/>
+                              <a:uFillTx/>
+                              <a:latin typeface="Cambria Math" panose="02040503050406030204" pitchFamily="18" charset="0"/>
+                              <a:ea typeface="+mn-ea"/>
+                              <a:cs typeface="+mn-cs"/>
+                            </a:rPr>
+                            <m:t>1</m:t>
+                          </m:r>
+                          <m:r>
+                            <a:rPr kumimoji="0" lang="en-US" sz="1800" b="0" i="1" u="none" strike="noStrike" kern="1200" cap="none" spc="0" normalizeH="0" baseline="0" noProof="0" smtClean="0">
+                              <a:ln>
+                                <a:noFill/>
+                              </a:ln>
+                              <a:solidFill>
+                                <a:prstClr val="black"/>
+                              </a:solidFill>
+                              <a:effectLst/>
+                              <a:uLnTx/>
+                              <a:uFillTx/>
+                              <a:latin typeface="Cambria Math" panose="02040503050406030204" pitchFamily="18" charset="0"/>
+                              <a:ea typeface="+mn-ea"/>
+                              <a:cs typeface="+mn-cs"/>
+                            </a:rPr>
+                            <m:t>.</m:t>
+                          </m:r>
+                          <m:r>
+                            <a:rPr kumimoji="0" lang="en-US" sz="1800" b="0" i="1" u="none" strike="noStrike" kern="1200" cap="none" spc="0" normalizeH="0" baseline="0" noProof="0" smtClean="0">
+                              <a:ln>
+                                <a:noFill/>
+                              </a:ln>
+                              <a:solidFill>
+                                <a:prstClr val="black"/>
+                              </a:solidFill>
+                              <a:effectLst/>
+                              <a:uLnTx/>
+                              <a:uFillTx/>
+                              <a:latin typeface="Cambria Math" panose="02040503050406030204" pitchFamily="18" charset="0"/>
+                              <a:ea typeface="+mn-ea"/>
+                              <a:cs typeface="+mn-cs"/>
+                            </a:rPr>
+                            <m:t>96</m:t>
+                          </m:r>
+                          <m:r>
+                            <a:rPr kumimoji="0" lang="en-US" sz="1800" b="0" i="1" u="none" strike="noStrike" kern="1200" cap="none" spc="0" normalizeH="0" baseline="0" noProof="0" smtClean="0">
+                              <a:ln>
+                                <a:noFill/>
+                              </a:ln>
+                              <a:solidFill>
+                                <a:prstClr val="black"/>
+                              </a:solidFill>
+                              <a:effectLst/>
+                              <a:uLnTx/>
+                              <a:uFillTx/>
+                              <a:latin typeface="Cambria Math" panose="02040503050406030204" pitchFamily="18" charset="0"/>
+                              <a:ea typeface="+mn-ea"/>
+                              <a:cs typeface="+mn-cs"/>
+                            </a:rPr>
+                            <m:t>(.</m:t>
+                          </m:r>
+                          <m:r>
+                            <a:rPr kumimoji="0" lang="en-US" sz="1800" b="0" i="1" u="none" strike="noStrike" kern="1200" cap="none" spc="0" normalizeH="0" baseline="0" noProof="0" smtClean="0">
+                              <a:ln>
+                                <a:noFill/>
+                              </a:ln>
+                              <a:solidFill>
+                                <a:prstClr val="black"/>
+                              </a:solidFill>
+                              <a:effectLst/>
+                              <a:uLnTx/>
+                              <a:uFillTx/>
+                              <a:latin typeface="Cambria Math" panose="02040503050406030204" pitchFamily="18" charset="0"/>
+                              <a:ea typeface="+mn-ea"/>
+                              <a:cs typeface="+mn-cs"/>
+                            </a:rPr>
+                            <m:t>63</m:t>
+                          </m:r>
+                          <m:r>
+                            <a:rPr kumimoji="0" lang="en-US" sz="1800" b="0" i="1" u="none" strike="noStrike" kern="1200" cap="none" spc="0" normalizeH="0" baseline="0" noProof="0" smtClean="0">
+                              <a:ln>
+                                <a:noFill/>
+                              </a:ln>
+                              <a:solidFill>
+                                <a:prstClr val="black"/>
+                              </a:solidFill>
+                              <a:effectLst/>
+                              <a:uLnTx/>
+                              <a:uFillTx/>
+                              <a:latin typeface="Cambria Math" panose="02040503050406030204" pitchFamily="18" charset="0"/>
+                              <a:ea typeface="+mn-ea"/>
+                              <a:cs typeface="+mn-cs"/>
+                            </a:rPr>
+                            <m:t>) </m:t>
                           </m:r>
                         </m:e>
                       </m:d>
@@ -23995,7 +24288,109 @@
                               <a:ea typeface="+mn-ea"/>
                               <a:cs typeface="+mn-cs"/>
                             </a:rPr>
-                            <m:t>67.77, 70.23</m:t>
+                            <m:t>67</m:t>
+                          </m:r>
+                          <m:r>
+                            <a:rPr kumimoji="0" lang="en-US" sz="1800" b="0" i="1" u="none" strike="noStrike" kern="1200" cap="none" spc="0" normalizeH="0" baseline="0" noProof="0" smtClean="0">
+                              <a:ln>
+                                <a:noFill/>
+                              </a:ln>
+                              <a:solidFill>
+                                <a:prstClr val="black"/>
+                              </a:solidFill>
+                              <a:effectLst/>
+                              <a:uLnTx/>
+                              <a:uFillTx/>
+                              <a:latin typeface="Cambria Math" panose="02040503050406030204" pitchFamily="18" charset="0"/>
+                              <a:ea typeface="+mn-ea"/>
+                              <a:cs typeface="+mn-cs"/>
+                            </a:rPr>
+                            <m:t>.</m:t>
+                          </m:r>
+                          <m:r>
+                            <a:rPr kumimoji="0" lang="en-US" sz="1800" b="0" i="1" u="none" strike="noStrike" kern="1200" cap="none" spc="0" normalizeH="0" baseline="0" noProof="0" smtClean="0">
+                              <a:ln>
+                                <a:noFill/>
+                              </a:ln>
+                              <a:solidFill>
+                                <a:prstClr val="black"/>
+                              </a:solidFill>
+                              <a:effectLst/>
+                              <a:uLnTx/>
+                              <a:uFillTx/>
+                              <a:latin typeface="Cambria Math" panose="02040503050406030204" pitchFamily="18" charset="0"/>
+                              <a:ea typeface="+mn-ea"/>
+                              <a:cs typeface="+mn-cs"/>
+                            </a:rPr>
+                            <m:t>77</m:t>
+                          </m:r>
+                          <m:r>
+                            <a:rPr kumimoji="0" lang="en-US" sz="1800" b="0" i="1" u="none" strike="noStrike" kern="1200" cap="none" spc="0" normalizeH="0" baseline="0" noProof="0" smtClean="0">
+                              <a:ln>
+                                <a:noFill/>
+                              </a:ln>
+                              <a:solidFill>
+                                <a:prstClr val="black"/>
+                              </a:solidFill>
+                              <a:effectLst/>
+                              <a:uLnTx/>
+                              <a:uFillTx/>
+                              <a:latin typeface="Cambria Math" panose="02040503050406030204" pitchFamily="18" charset="0"/>
+                              <a:ea typeface="+mn-ea"/>
+                              <a:cs typeface="+mn-cs"/>
+                            </a:rPr>
+                            <m:t>, </m:t>
+                          </m:r>
+                          <m:r>
+                            <a:rPr kumimoji="0" lang="en-US" sz="1800" b="0" i="1" u="none" strike="noStrike" kern="1200" cap="none" spc="0" normalizeH="0" baseline="0" noProof="0" smtClean="0">
+                              <a:ln>
+                                <a:noFill/>
+                              </a:ln>
+                              <a:solidFill>
+                                <a:prstClr val="black"/>
+                              </a:solidFill>
+                              <a:effectLst/>
+                              <a:uLnTx/>
+                              <a:uFillTx/>
+                              <a:latin typeface="Cambria Math" panose="02040503050406030204" pitchFamily="18" charset="0"/>
+                              <a:ea typeface="+mn-ea"/>
+                              <a:cs typeface="+mn-cs"/>
+                            </a:rPr>
+                            <m:t>70</m:t>
+                          </m:r>
+                          <m:r>
+                            <a:rPr kumimoji="0" lang="en-US" sz="1800" b="0" i="1" u="none" strike="noStrike" kern="1200" cap="none" spc="0" normalizeH="0" baseline="0" noProof="0" smtClean="0">
+                              <a:ln>
+                                <a:noFill/>
+                              </a:ln>
+                              <a:solidFill>
+                                <a:prstClr val="black"/>
+                              </a:solidFill>
+                              <a:effectLst/>
+                              <a:uLnTx/>
+                              <a:uFillTx/>
+                              <a:latin typeface="Cambria Math" panose="02040503050406030204" pitchFamily="18" charset="0"/>
+                              <a:ea typeface="+mn-ea"/>
+                              <a:cs typeface="+mn-cs"/>
+                            </a:rPr>
+                            <m:t>.</m:t>
+                          </m:r>
+                          <m:r>
+                            <a:rPr kumimoji="0" lang="en-US" sz="1800" b="0" i="1" u="none" strike="noStrike" kern="1200" cap="none" spc="0" normalizeH="0" baseline="0" noProof="0" smtClean="0">
+                              <a:ln>
+                                <a:noFill/>
+                              </a:ln>
+                              <a:solidFill>
+                                <a:prstClr val="black"/>
+                              </a:solidFill>
+                              <a:effectLst/>
+                              <a:uLnTx/>
+                              <a:uFillTx/>
+                              <a:latin typeface="Cambria Math" panose="02040503050406030204" pitchFamily="18" charset="0"/>
+                              <a:ea typeface="+mn-ea"/>
+                              <a:cs typeface="+mn-cs"/>
+                            </a:rPr>
+                            <m:t>23</m:t>
                           </m:r>
                         </m:e>
                       </m:d>
@@ -29528,7 +29923,7 @@
           <p:nvPr>
             <p:extLst>
               <p:ext uri="{D42A27DB-BD31-4B8C-83A1-F6EECF244321}">
-                <p14:modId xmlns:p14="http://schemas.microsoft.com/office/powerpoint/2010/main" val="3459852978"/>
+                <p14:modId xmlns:p14="http://schemas.microsoft.com/office/powerpoint/2010/main" val="3924662709"/>
               </p:ext>
             </p:extLst>
           </p:nvPr>
@@ -29576,11 +29971,13 @@
                         <a:buNone/>
                       </a:pPr>
                       <a:r>
-                        <a:rPr lang="en-US" sz="2600" b="0" cap="none" spc="60">
+                        <a:rPr lang="en-US" sz="2000" b="0" cap="none" spc="60" dirty="0">
                           <a:solidFill>
                             <a:schemeClr val="bg1"/>
                           </a:solidFill>
                           <a:effectLst/>
+                          <a:latin typeface="Arial" panose="020B0604020202020204" pitchFamily="34" charset="0"/>
+                          <a:cs typeface="Arial" panose="020B0604020202020204" pitchFamily="34" charset="0"/>
                         </a:rPr>
                         <a:t>Group</a:t>
                       </a:r>
@@ -29614,11 +30011,13 @@
                         <a:buNone/>
                       </a:pPr>
                       <a:r>
-                        <a:rPr lang="en-US" sz="2600" b="0" cap="none" spc="60">
+                        <a:rPr lang="en-US" sz="2000" b="0" cap="none" spc="60">
                           <a:solidFill>
                             <a:schemeClr val="bg1"/>
                           </a:solidFill>
                           <a:effectLst/>
+                          <a:latin typeface="Arial" panose="020B0604020202020204" pitchFamily="34" charset="0"/>
+                          <a:cs typeface="Arial" panose="020B0604020202020204" pitchFamily="34" charset="0"/>
                         </a:rPr>
                         <a:t>Odds Ratio (OR)</a:t>
                       </a:r>
@@ -29652,11 +30051,13 @@
                         <a:buNone/>
                       </a:pPr>
                       <a:r>
-                        <a:rPr lang="en-US" sz="2600" b="0" cap="none" spc="60">
+                        <a:rPr lang="en-US" sz="2000" b="0" cap="none" spc="60">
                           <a:solidFill>
                             <a:schemeClr val="bg1"/>
                           </a:solidFill>
                           <a:effectLst/>
+                          <a:latin typeface="Arial" panose="020B0604020202020204" pitchFamily="34" charset="0"/>
+                          <a:cs typeface="Arial" panose="020B0604020202020204" pitchFamily="34" charset="0"/>
                         </a:rPr>
                         <a:t>Explanation of Effect Size</a:t>
                       </a:r>
@@ -29697,11 +30098,13 @@
                         <a:buNone/>
                       </a:pPr>
                       <a:r>
-                        <a:rPr lang="en-US" sz="2200" b="0" cap="none" spc="0">
+                        <a:rPr lang="en-US" sz="2000" b="0" cap="none" spc="0" dirty="0">
                           <a:solidFill>
                             <a:schemeClr val="tx1"/>
                           </a:solidFill>
                           <a:effectLst/>
+                          <a:latin typeface="Arial" panose="020B0604020202020204" pitchFamily="34" charset="0"/>
+                          <a:cs typeface="Arial" panose="020B0604020202020204" pitchFamily="34" charset="0"/>
                         </a:rPr>
                         <a:t>Age &lt; 65</a:t>
                       </a:r>
@@ -29735,11 +30138,13 @@
                         <a:buNone/>
                       </a:pPr>
                       <a:r>
-                        <a:rPr lang="en-US" sz="2200" b="0" cap="none" spc="0">
+                        <a:rPr lang="en-US" sz="2000" b="0" cap="none" spc="0" dirty="0">
                           <a:solidFill>
                             <a:schemeClr val="tx1"/>
                           </a:solidFill>
                           <a:effectLst/>
+                          <a:latin typeface="Arial" panose="020B0604020202020204" pitchFamily="34" charset="0"/>
+                          <a:cs typeface="Arial" panose="020B0604020202020204" pitchFamily="34" charset="0"/>
                         </a:rPr>
                         <a:t>1.80x</a:t>
                       </a:r>
@@ -29773,11 +30178,13 @@
                         <a:buNone/>
                       </a:pPr>
                       <a:r>
-                        <a:rPr lang="en-US" sz="2200" b="0" cap="none" spc="0">
+                        <a:rPr lang="en-US" sz="2000" b="0" cap="none" spc="0" dirty="0">
                           <a:solidFill>
                             <a:schemeClr val="tx1"/>
                           </a:solidFill>
                           <a:effectLst/>
+                          <a:latin typeface="Arial" panose="020B0604020202020204" pitchFamily="34" charset="0"/>
+                          <a:cs typeface="Arial" panose="020B0604020202020204" pitchFamily="34" charset="0"/>
                         </a:rPr>
                         <a:t>Younger adults who are food insecure are 80% more likely to end up in the ER.</a:t>
                       </a:r>
@@ -29818,11 +30225,13 @@
                         <a:buNone/>
                       </a:pPr>
                       <a:r>
-                        <a:rPr lang="en-US" sz="2200" b="0" cap="none" spc="0">
+                        <a:rPr lang="en-US" sz="2000" b="0" cap="none" spc="0">
                           <a:solidFill>
                             <a:schemeClr val="tx1"/>
                           </a:solidFill>
                           <a:effectLst/>
+                          <a:latin typeface="Arial" panose="020B0604020202020204" pitchFamily="34" charset="0"/>
+                          <a:cs typeface="Arial" panose="020B0604020202020204" pitchFamily="34" charset="0"/>
                         </a:rPr>
                         <a:t>Age &gt;= 65</a:t>
                       </a:r>
@@ -29861,11 +30270,13 @@
                         <a:buNone/>
                       </a:pPr>
                       <a:r>
-                        <a:rPr lang="en-US" sz="2200" b="0" cap="none" spc="0">
+                        <a:rPr lang="en-US" sz="2000" b="0" cap="none" spc="0">
                           <a:solidFill>
                             <a:schemeClr val="tx1"/>
                           </a:solidFill>
                           <a:effectLst/>
+                          <a:latin typeface="Arial" panose="020B0604020202020204" pitchFamily="34" charset="0"/>
+                          <a:cs typeface="Arial" panose="020B0604020202020204" pitchFamily="34" charset="0"/>
                         </a:rPr>
                         <a:t>1.27x</a:t>
                       </a:r>
@@ -29904,11 +30315,13 @@
                         <a:buNone/>
                       </a:pPr>
                       <a:r>
-                        <a:rPr lang="en-US" sz="2200" b="0" cap="none" spc="0">
+                        <a:rPr lang="en-US" sz="2000" b="0" cap="none" spc="0" dirty="0">
                           <a:solidFill>
                             <a:schemeClr val="tx1"/>
                           </a:solidFill>
                           <a:effectLst/>
+                          <a:latin typeface="Arial" panose="020B0604020202020204" pitchFamily="34" charset="0"/>
+                          <a:cs typeface="Arial" panose="020B0604020202020204" pitchFamily="34" charset="0"/>
                         </a:rPr>
                         <a:t>Older persons who are food insecure are 27% more likely to end up in the ER.</a:t>
                       </a:r>
@@ -29954,11 +30367,13 @@
                         <a:buNone/>
                       </a:pPr>
                       <a:r>
-                        <a:rPr lang="en-US" sz="2200" b="0" cap="none" spc="0">
+                        <a:rPr lang="en-US" sz="2000" b="0" cap="none" spc="0">
                           <a:solidFill>
                             <a:schemeClr val="tx1"/>
                           </a:solidFill>
                           <a:effectLst/>
+                          <a:latin typeface="Arial" panose="020B0604020202020204" pitchFamily="34" charset="0"/>
+                          <a:cs typeface="Arial" panose="020B0604020202020204" pitchFamily="34" charset="0"/>
                         </a:rPr>
                         <a:t>The Buffer effect of Medicare</a:t>
                       </a:r>
@@ -29993,11 +30408,13 @@
                         <a:buNone/>
                       </a:pPr>
                       <a:r>
-                        <a:rPr lang="en-US" sz="2200" b="0" cap="none" spc="0">
+                        <a:rPr lang="en-US" sz="2000" b="0" cap="none" spc="0">
                           <a:solidFill>
                             <a:schemeClr val="tx1"/>
                           </a:solidFill>
                           <a:effectLst/>
+                          <a:latin typeface="Arial" panose="020B0604020202020204" pitchFamily="34" charset="0"/>
+                          <a:cs typeface="Arial" panose="020B0604020202020204" pitchFamily="34" charset="0"/>
                         </a:rPr>
                         <a:t>0.70x</a:t>
                       </a:r>
@@ -30032,11 +30449,13 @@
                         <a:buNone/>
                       </a:pPr>
                       <a:r>
-                        <a:rPr lang="en-US" sz="2200" b="0" cap="none" spc="0">
+                        <a:rPr lang="en-US" sz="2000" b="0" cap="none" spc="0" dirty="0">
                           <a:solidFill>
                             <a:schemeClr val="tx1"/>
                           </a:solidFill>
                           <a:effectLst/>
+                          <a:latin typeface="Arial" panose="020B0604020202020204" pitchFamily="34" charset="0"/>
+                          <a:cs typeface="Arial" panose="020B0604020202020204" pitchFamily="34" charset="0"/>
                         </a:rPr>
                         <a:t>Medicare/social safety nets cut the link between hunger and the ER by 30%.</a:t>
                       </a:r>

</xml_diff>